<commit_message>
audit: final technical audit report, telemetry serialization fix, and frontend resilience
- Include comprehensive repository technical audit (eco_loop_building_agents_audit.md)
- Fix Pydantic computed_field serialization in backend/models.py for telemetry properties
- Add ErrorBoundary in frontend/src/main.jsx to guard against UI crashes
- Update submission presentation decks (Eco_Loop_Submission.pptx & PDFs)
- Purge residual Office temporary lock file
</commit_message>
<xml_diff>
--- a/Eco_Loop_Submission.pptx
+++ b/Eco_Loop_Submission.pptx
@@ -3701,7 +3701,7 @@
           <a:p>
             <a:pPr algn="l"/>
             <a:r>
-              <a:rPr sz="1400" b="1" i="0">
+              <a:rPr sz="1400" b="1" i="0" dirty="0">
                 <a:solidFill>
                   <a:srgbClr val="0D2D6E"/>
                 </a:solidFill>
@@ -8509,7 +8509,7 @@
         <p:spPr>
           <a:xfrm>
             <a:off x="182880" y="1371600"/>
-            <a:ext cx="2560320" cy="914400"/>
+            <a:ext cx="1930370" cy="914400"/>
           </a:xfrm>
           <a:prstGeom prst="rect">
             <a:avLst/>
@@ -8552,7 +8552,7 @@
         </p:nvSpPr>
         <p:spPr>
           <a:xfrm>
-            <a:off x="73153" y="1417320"/>
+            <a:off x="-58943" y="1507382"/>
             <a:ext cx="2414015" cy="822960"/>
           </a:xfrm>
           <a:prstGeom prst="rect">
@@ -8568,13 +8568,22 @@
           <a:p>
             <a:pPr algn="ctr"/>
             <a:r>
-              <a:rPr sz="1100" b="1" i="0">
+              <a:rPr sz="1100" b="1" i="0" dirty="0" err="1">
                 <a:solidFill>
                   <a:srgbClr val="FFFFFF"/>
                 </a:solidFill>
                 <a:latin typeface="Calibri"/>
               </a:rPr>
-              <a:t>EnergyPlus
+              <a:t>EnergyPlus</a:t>
+            </a:r>
+            <a:r>
+              <a:rPr sz="1100" b="1" i="0" dirty="0">
+                <a:solidFill>
+                  <a:srgbClr val="FFFFFF"/>
+                </a:solidFill>
+                <a:latin typeface="Calibri"/>
+              </a:rPr>
+              <a:t>
 Simulation
 (5-zone office)</a:t>
             </a:r>
@@ -8589,8 +8598,8 @@
         </p:nvSpPr>
         <p:spPr>
           <a:xfrm>
-            <a:off x="3687096" y="1371600"/>
-            <a:ext cx="2073623" cy="884609"/>
+            <a:off x="3362485" y="1415598"/>
+            <a:ext cx="1703291" cy="884609"/>
           </a:xfrm>
           <a:prstGeom prst="rect">
             <a:avLst/>
@@ -8633,8 +8642,8 @@
         </p:nvSpPr>
         <p:spPr>
           <a:xfrm>
-            <a:off x="3507954" y="1485900"/>
-            <a:ext cx="2414015" cy="822960"/>
+            <a:off x="3196321" y="1544647"/>
+            <a:ext cx="1902445" cy="600164"/>
           </a:xfrm>
           <a:prstGeom prst="rect">
             <a:avLst/>
@@ -8676,7 +8685,7 @@
         </p:nvGrpSpPr>
         <p:grpSpPr>
           <a:xfrm>
-            <a:off x="5760719" y="2205523"/>
+            <a:off x="5512951" y="2304288"/>
             <a:ext cx="2560320" cy="979981"/>
             <a:chOff x="6126480" y="822960"/>
             <a:chExt cx="2560320" cy="979981"/>
@@ -9114,7 +9123,7 @@
         </p:nvSpPr>
         <p:spPr>
           <a:xfrm>
-            <a:off x="2724912" y="1730429"/>
+            <a:off x="2206193" y="1705357"/>
             <a:ext cx="2743200" cy="320040"/>
           </a:xfrm>
           <a:prstGeom prst="rect">
@@ -9149,7 +9158,7 @@
         </p:nvSpPr>
         <p:spPr>
           <a:xfrm>
-            <a:off x="5810561" y="3124889"/>
+            <a:off x="6343675" y="3200400"/>
             <a:ext cx="2743200" cy="320040"/>
           </a:xfrm>
           <a:prstGeom prst="rect">

</xml_diff>